<commit_message>
feat: updated PPT and timeline
</commit_message>
<xml_diff>
--- a/SIH_Presentation.pptx
+++ b/SIH_Presentation.pptx
@@ -5691,11 +5691,14 @@
               <a:t>Team ID: </a:t>
             </a:r>
             <a:r>
-              <a:rPr sz="2000" b="0" dirty="0">
-                <a:latin typeface="Arial"/>
-              </a:rPr>
-              <a:t>[Your Team ID]</a:t>
-            </a:r>
+              <a:rPr lang="en-US" sz="2000" b="0" dirty="0">
+                <a:latin typeface="Arial"/>
+              </a:rPr>
+              <a:t>#81</a:t>
+            </a:r>
+            <a:endParaRPr sz="2000" b="0" dirty="0">
+              <a:latin typeface="Arial"/>
+            </a:endParaRPr>
           </a:p>
           <a:p>
             <a:pPr>
@@ -5784,6 +5787,18 @@
   <p:clrMapOvr>
     <a:masterClrMapping/>
   </p:clrMapOvr>
+  <mc:AlternateContent xmlns:mc="http://schemas.openxmlformats.org/markup-compatibility/2006">
+    <mc:Choice xmlns:p14="http://schemas.microsoft.com/office/powerpoint/2010/main" Requires="p14">
+      <p:transition spd="med" p14:dur="700">
+        <p:fade/>
+      </p:transition>
+    </mc:Choice>
+    <mc:Fallback>
+      <p:transition spd="med">
+        <p:fade/>
+      </p:transition>
+    </mc:Fallback>
+  </mc:AlternateContent>
 </p:sld>
 </file>
 
@@ -5974,8 +5989,8 @@
           <a:p>
             <a:pPr algn="ctr"/>
             <a:r>
-              <a:rPr lang="en-US" dirty="0"/>
-              <a:t>Team Name</a:t>
+              <a:rPr lang="en-US" dirty="0" err="1"/>
+              <a:t>BharatCodex</a:t>
             </a:r>
             <a:endParaRPr lang="en-IN" dirty="0"/>
           </a:p>
@@ -6190,10 +6205,22 @@
               <a:rPr sz="1300" b="0" dirty="0">
                 <a:latin typeface="Arial"/>
               </a:rPr>
-              <a:t>Companies keep using their existing SAP/Oracle item codes—</a:t>
-            </a:r>
-            <a:r>
-              <a:rPr sz="1300" b="0" dirty="0" err="1">
+              <a:t>Companies keep using their existing SAP/Oracle item </a:t>
+            </a:r>
+            <a:r>
+              <a:rPr sz="1300" b="0">
+                <a:latin typeface="Arial"/>
+              </a:rPr>
+              <a:t>codes</a:t>
+            </a:r>
+            <a:r>
+              <a:rPr lang="en-US" sz="1300">
+                <a:latin typeface="Arial"/>
+              </a:rPr>
+              <a:t>. </a:t>
+            </a:r>
+            <a:r>
+              <a:rPr sz="1300" b="0">
                 <a:latin typeface="Arial"/>
               </a:rPr>
               <a:t>Samanvay</a:t>
@@ -6391,6 +6418,9 @@
   <p:clrMapOvr>
     <a:masterClrMapping/>
   </p:clrMapOvr>
+  <p:transition spd="slow">
+    <p:wipe/>
+  </p:transition>
 </p:sld>
 </file>
 
@@ -6578,8 +6608,8 @@
           <a:p>
             <a:pPr algn="ctr"/>
             <a:r>
-              <a:rPr lang="en-US" dirty="0"/>
-              <a:t>Your Team Name</a:t>
+              <a:rPr lang="en-US" dirty="0" err="1"/>
+              <a:t>BharatCodex</a:t>
             </a:r>
             <a:endParaRPr lang="en-IN" dirty="0"/>
           </a:p>
@@ -6630,7 +6660,7 @@
           <p:nvPr>
             <p:extLst>
               <p:ext uri="{D42A27DB-BD31-4B8C-83A1-F6EECF244321}">
-                <p14:modId xmlns:p14="http://schemas.microsoft.com/office/powerpoint/2010/main" val="2594096567"/>
+                <p14:modId xmlns:p14="http://schemas.microsoft.com/office/powerpoint/2010/main" val="2879413759"/>
               </p:ext>
             </p:extLst>
           </p:nvPr>
@@ -6813,10 +6843,34 @@
                     <a:lstStyle/>
                     <a:p>
                       <a:r>
-                        <a:rPr sz="1000" b="0"/>
-                        <a:t>PaddleOCR, PyMuPDF, DeBERTa-v3, BGE-M3</a:t>
+                        <a:rPr sz="1000" b="0" dirty="0" err="1"/>
+                        <a:t>PaddleOCR</a:t>
                       </a:r>
-                      <a:endParaRPr sz="1000" b="0">
+                      <a:r>
+                        <a:rPr lang="en-US" sz="1000" b="0" dirty="0"/>
+                        <a:t>/</a:t>
+                      </a:r>
+                      <a:r>
+                        <a:rPr sz="1000" b="0" dirty="0" err="1"/>
+                        <a:t>PyMuPDF</a:t>
+                      </a:r>
+                      <a:r>
+                        <a:rPr lang="en-US" sz="1000" b="0" dirty="0"/>
+                        <a:t>/</a:t>
+                      </a:r>
+                      <a:r>
+                        <a:rPr lang="en-US" sz="1000" b="0" dirty="0" err="1"/>
+                        <a:t>PDFPlumber</a:t>
+                      </a:r>
+                      <a:r>
+                        <a:rPr lang="en-US" sz="1000" b="0" dirty="0"/>
+                        <a:t> or related</a:t>
+                      </a:r>
+                      <a:r>
+                        <a:rPr sz="1000" b="0" dirty="0"/>
+                        <a:t>, DeBERTa-v3, BGE-M3</a:t>
+                      </a:r>
+                      <a:endParaRPr sz="1000" b="0" dirty="0">
                         <a:latin typeface="Arial"/>
                       </a:endParaRPr>
                     </a:p>
@@ -7258,7 +7312,7 @@
         <p:spPr>
           <a:xfrm>
             <a:off x="329773" y="1095375"/>
-            <a:ext cx="2515563" cy="1446550"/>
+            <a:ext cx="2515563" cy="1554272"/>
           </a:xfrm>
           <a:prstGeom prst="rect">
             <a:avLst/>
@@ -7316,7 +7370,7 @@
                 <a:latin typeface="Arial" panose="020B0604020202020204" pitchFamily="34" charset="0"/>
                 <a:cs typeface="Arial" panose="020B0604020202020204" pitchFamily="34" charset="0"/>
               </a:rPr>
-              <a:t> + </a:t>
+              <a:t>/</a:t>
             </a:r>
             <a:r>
               <a:rPr lang="en-IN" sz="1050" dirty="0" err="1">
@@ -7324,6 +7378,20 @@
                 <a:cs typeface="Arial" panose="020B0604020202020204" pitchFamily="34" charset="0"/>
               </a:rPr>
               <a:t>PyMuPDF</a:t>
+            </a:r>
+            <a:r>
+              <a:rPr lang="en-IN" sz="1050" dirty="0">
+                <a:latin typeface="Arial" panose="020B0604020202020204" pitchFamily="34" charset="0"/>
+                <a:cs typeface="Arial" panose="020B0604020202020204" pitchFamily="34" charset="0"/>
+              </a:rPr>
+              <a:t>/</a:t>
+            </a:r>
+            <a:r>
+              <a:rPr lang="en-IN" sz="1050" dirty="0" err="1">
+                <a:latin typeface="Arial" panose="020B0604020202020204" pitchFamily="34" charset="0"/>
+                <a:cs typeface="Arial" panose="020B0604020202020204" pitchFamily="34" charset="0"/>
+              </a:rPr>
+              <a:t>PDFPlumber</a:t>
             </a:r>
             <a:r>
               <a:rPr lang="en-IN" sz="1050" dirty="0">
@@ -7564,7 +7632,7 @@
         <p:spPr>
           <a:xfrm>
             <a:off x="8841785" y="1059580"/>
-            <a:ext cx="2515563" cy="1708160"/>
+            <a:ext cx="2673612" cy="1546577"/>
           </a:xfrm>
           <a:prstGeom prst="rect">
             <a:avLst/>
@@ -7652,9 +7720,9 @@
           <p:nvPr/>
         </p:nvCxnSpPr>
         <p:spPr>
-          <a:xfrm>
+          <a:xfrm flipV="1">
             <a:off x="2845336" y="1818650"/>
-            <a:ext cx="471605" cy="0"/>
+            <a:ext cx="471605" cy="53861"/>
           </a:xfrm>
           <a:prstGeom prst="straightConnector1">
             <a:avLst/>
@@ -7761,6 +7829,9 @@
   <p:clrMapOvr>
     <a:masterClrMapping/>
   </p:clrMapOvr>
+  <p:transition spd="slow">
+    <p:wipe/>
+  </p:transition>
 </p:sld>
 </file>
 
@@ -8014,8 +8085,8 @@
           <a:p>
             <a:pPr algn="ctr"/>
             <a:r>
-              <a:rPr lang="en-US" dirty="0"/>
-              <a:t>Your Team Name</a:t>
+              <a:rPr lang="en-US" dirty="0" err="1"/>
+              <a:t>BharatCodex</a:t>
             </a:r>
             <a:endParaRPr lang="en-IN" dirty="0"/>
           </a:p>
@@ -8066,7 +8137,7 @@
         <p:spPr>
           <a:xfrm>
             <a:off x="404640" y="1439199"/>
-            <a:ext cx="3632219" cy="1446550"/>
+            <a:ext cx="3632219" cy="877163"/>
           </a:xfrm>
           <a:prstGeom prst="rect">
             <a:avLst/>
@@ -8091,7 +8162,19 @@
               <a:rPr sz="1200" b="0" dirty="0">
                 <a:latin typeface="Arial"/>
               </a:rPr>
-              <a:t>Searches through 10+ million spare parts in under 15 milliseconds, handling large enterprise catalog uploads with instant safety checks.</a:t>
+              <a:t>Searches through </a:t>
+            </a:r>
+            <a:r>
+              <a:rPr lang="en-US" sz="1200" b="0" dirty="0">
+                <a:latin typeface="Arial"/>
+              </a:rPr>
+              <a:t>100,000 </a:t>
+            </a:r>
+            <a:r>
+              <a:rPr sz="1200" b="0" dirty="0">
+                <a:latin typeface="Arial"/>
+              </a:rPr>
+              <a:t>spare parts in under 15 milliseconds, handling large enterprise catalog uploads with instant safety checks.</a:t>
             </a:r>
           </a:p>
         </p:txBody>
@@ -8126,14 +8209,14 @@
           <a:p>
             <a:pPr algn="just"/>
             <a:r>
-              <a:rPr sz="1500" b="1">
+              <a:rPr sz="1500" b="1" dirty="0">
                 <a:latin typeface="Arial"/>
               </a:rPr>
               <a:t>Operational Ease
 </a:t>
             </a:r>
             <a:r>
-              <a:rPr sz="1200" b="0">
+              <a:rPr sz="1200" b="0" dirty="0">
                 <a:latin typeface="Arial"/>
               </a:rPr>
               <a:t>Reads both clear digital PDFs and blurry mobile scans; intuitive web dashboard requires zero special training for warehouse and plant staff.</a:t>
@@ -8556,6 +8639,9 @@
   <p:clrMapOvr>
     <a:masterClrMapping/>
   </p:clrMapOvr>
+  <p:transition spd="slow">
+    <p:wipe/>
+  </p:transition>
 </p:sld>
 </file>
 
@@ -8809,8 +8895,8 @@
           <a:p>
             <a:pPr algn="ctr"/>
             <a:r>
-              <a:rPr lang="en-US" dirty="0"/>
-              <a:t>Your Team Name</a:t>
+              <a:rPr lang="en-US" dirty="0" err="1"/>
+              <a:t>BharatCodex</a:t>
             </a:r>
             <a:endParaRPr lang="en-IN" dirty="0"/>
           </a:p>
@@ -8861,7 +8947,7 @@
         <p:spPr>
           <a:xfrm>
             <a:off x="609600" y="1400092"/>
-            <a:ext cx="3632219" cy="4389120"/>
+            <a:ext cx="3632219" cy="3544560"/>
           </a:xfrm>
           <a:prstGeom prst="rect">
             <a:avLst/>
@@ -8880,110 +8966,134 @@
               </a:spcAft>
             </a:pPr>
             <a:r>
-              <a:rPr sz="1600" b="1">
+              <a:rPr sz="1600" b="1" dirty="0">
                 <a:latin typeface="Arial"/>
               </a:rPr>
               <a:t>Target Audience &amp; Operations</a:t>
             </a:r>
           </a:p>
           <a:p>
-            <a:pPr>
+            <a:pPr algn="just">
               <a:spcAft>
                 <a:spcPts val="800"/>
               </a:spcAft>
             </a:pPr>
             <a:r>
-              <a:rPr sz="1200" b="0">
+              <a:rPr sz="1200" b="0" dirty="0">
                 <a:latin typeface="Arial"/>
               </a:rPr>
               <a:t>• </a:t>
             </a:r>
             <a:r>
-              <a:rPr sz="1200" b="1">
+              <a:rPr sz="1200" b="1" dirty="0">
                 <a:latin typeface="Arial"/>
               </a:rPr>
               <a:t>Who It Helps: </a:t>
             </a:r>
             <a:r>
-              <a:rPr sz="1200" b="0">
-                <a:latin typeface="Arial"/>
-              </a:rPr>
-              <a:t>Ministry of Petroleum (MoPNG), Oil PSUs (IOCL, ONGC, BPCL, HPCL, GAIL), refinery engineers, and depot purchase managers.</a:t>
-            </a:r>
-          </a:p>
-          <a:p>
-            <a:pPr>
+              <a:rPr sz="1200" b="0" dirty="0">
+                <a:latin typeface="Arial"/>
+              </a:rPr>
+              <a:t>Ministry of Petroleum (</a:t>
+            </a:r>
+            <a:r>
+              <a:rPr sz="1200" b="0" dirty="0" err="1">
+                <a:latin typeface="Arial"/>
+              </a:rPr>
+              <a:t>MoPNG</a:t>
+            </a:r>
+            <a:r>
+              <a:rPr sz="1200" b="0" dirty="0">
+                <a:latin typeface="Arial"/>
+              </a:rPr>
+              <a:t>), Oil PSUs (IOCL, ONGC, BPCL, HPCL, GAIL), refinery engineers, and depot purchase managers.</a:t>
+            </a:r>
+          </a:p>
+          <a:p>
+            <a:pPr algn="just">
               <a:spcAft>
                 <a:spcPts val="800"/>
               </a:spcAft>
             </a:pPr>
             <a:r>
-              <a:rPr sz="1200" b="0">
+              <a:rPr sz="1200" b="0" dirty="0">
                 <a:latin typeface="Arial"/>
               </a:rPr>
               <a:t>• </a:t>
             </a:r>
             <a:r>
-              <a:rPr sz="1200" b="1">
+              <a:rPr sz="1200" b="1" dirty="0">
                 <a:latin typeface="Arial"/>
               </a:rPr>
               <a:t>Emergency Spares in Under 48 Hours: </a:t>
             </a:r>
             <a:r>
-              <a:rPr sz="1200" b="0">
+              <a:rPr sz="1200" b="0" dirty="0">
                 <a:latin typeface="Arial"/>
               </a:rPr>
               <a:t>Cuts spare part procurement time from 4–6 weeks of public tendering down to under 48 hours via sister company depots.</a:t>
             </a:r>
           </a:p>
           <a:p>
-            <a:pPr>
+            <a:pPr algn="just">
               <a:spcAft>
                 <a:spcPts val="800"/>
               </a:spcAft>
             </a:pPr>
             <a:r>
-              <a:rPr sz="1200" b="0">
+              <a:rPr sz="1200" b="0" dirty="0">
                 <a:latin typeface="Arial"/>
               </a:rPr>
               <a:t>• </a:t>
             </a:r>
             <a:r>
-              <a:rPr sz="1200" b="1">
+              <a:rPr sz="1200" b="1" dirty="0">
                 <a:latin typeface="Arial"/>
               </a:rPr>
               <a:t>Cleans Up to 35% Duplicate Items: </a:t>
             </a:r>
             <a:r>
-              <a:rPr sz="1200" b="0">
+              <a:rPr sz="1200" b="0" dirty="0">
                 <a:latin typeface="Arial"/>
               </a:rPr>
               <a:t>Eliminates confusing duplicate item codes across legacy SAP systems, creating one clean, standardized master catalog.</a:t>
             </a:r>
           </a:p>
           <a:p>
-            <a:pPr>
+            <a:pPr algn="just">
               <a:spcAft>
                 <a:spcPts val="800"/>
               </a:spcAft>
             </a:pPr>
             <a:r>
-              <a:rPr sz="1200" b="0">
+              <a:rPr sz="1200" b="0" dirty="0">
                 <a:latin typeface="Arial"/>
               </a:rPr>
               <a:t>• </a:t>
             </a:r>
             <a:r>
-              <a:rPr sz="1200" b="1">
+              <a:rPr sz="1200" b="1" dirty="0">
                 <a:latin typeface="Arial"/>
               </a:rPr>
               <a:t>Prevents Costly Plant Shutdowns: </a:t>
             </a:r>
             <a:r>
-              <a:rPr sz="1200" b="0">
-                <a:latin typeface="Arial"/>
-              </a:rPr>
-              <a:t>Locates emergency replacement spares immediately, avoiding unplanned refinery outages that cost over ₹40 Lakhs per hour.</a:t>
+              <a:rPr sz="1200" b="0" dirty="0">
+                <a:latin typeface="Arial"/>
+              </a:rPr>
+              <a:t>Locates emergency replacement spares immediately, avoiding unplanned refinery outages that cost over </a:t>
+            </a:r>
+            <a:r>
+              <a:rPr lang="en-US" sz="1200" dirty="0">
+                <a:latin typeface="Arial"/>
+              </a:rPr>
+              <a:t>upwards to Tens of</a:t>
+            </a:r>
+            <a:r>
+              <a:rPr sz="1200" b="0" dirty="0">
+                <a:latin typeface="Arial"/>
+              </a:rPr>
+              <a:t> Lakhs per hour.</a:t>
             </a:r>
           </a:p>
         </p:txBody>
@@ -9003,7 +9113,7 @@
         <p:spPr>
           <a:xfrm>
             <a:off x="4484850" y="1400092"/>
-            <a:ext cx="3632219" cy="4389120"/>
+            <a:ext cx="3632219" cy="3544560"/>
           </a:xfrm>
           <a:prstGeom prst="rect">
             <a:avLst/>
@@ -9022,107 +9132,143 @@
               </a:spcAft>
             </a:pPr>
             <a:r>
-              <a:rPr sz="1600" b="1">
+              <a:rPr sz="1600" b="1" dirty="0">
                 <a:latin typeface="Arial"/>
               </a:rPr>
               <a:t>Economic &amp; Financial Impact</a:t>
             </a:r>
           </a:p>
           <a:p>
-            <a:pPr>
+            <a:pPr algn="just">
               <a:spcAft>
                 <a:spcPts val="800"/>
               </a:spcAft>
             </a:pPr>
             <a:r>
-              <a:rPr sz="1200" b="0">
+              <a:rPr sz="1200" b="0" dirty="0">
                 <a:latin typeface="Arial"/>
               </a:rPr>
               <a:t>• </a:t>
             </a:r>
             <a:r>
-              <a:rPr sz="1200" b="1">
-                <a:latin typeface="Arial"/>
-              </a:rPr>
-              <a:t>Unlocks ₹1,500+ Crores: </a:t>
-            </a:r>
-            <a:r>
-              <a:rPr sz="1200" b="0">
-                <a:latin typeface="Arial"/>
-              </a:rPr>
-              <a:t>Frees 15%–25% of dormant working capital trapped in idle, duplicate inventory across MoPNG enterprises.</a:t>
-            </a:r>
-          </a:p>
-          <a:p>
-            <a:pPr>
+              <a:rPr sz="1200" b="1" dirty="0">
+                <a:latin typeface="Arial"/>
+              </a:rPr>
+              <a:t>Unlocks ₹</a:t>
+            </a:r>
+            <a:r>
+              <a:rPr lang="en-US" sz="1200" b="1" dirty="0">
+                <a:latin typeface="Arial"/>
+              </a:rPr>
+              <a:t>100</a:t>
+            </a:r>
+            <a:r>
+              <a:rPr sz="1200" b="1" dirty="0">
+                <a:latin typeface="Arial"/>
+              </a:rPr>
+              <a:t>+ Crores: </a:t>
+            </a:r>
+            <a:r>
+              <a:rPr sz="1200" b="0" dirty="0">
+                <a:latin typeface="Arial"/>
+              </a:rPr>
+              <a:t>Frees 15%–25% of dormant working capital trapped in idle, duplicate inventory across </a:t>
+            </a:r>
+            <a:r>
+              <a:rPr sz="1200" b="0" dirty="0" err="1">
+                <a:latin typeface="Arial"/>
+              </a:rPr>
+              <a:t>MoPNG</a:t>
+            </a:r>
+            <a:r>
+              <a:rPr sz="1200" b="0" dirty="0">
+                <a:latin typeface="Arial"/>
+              </a:rPr>
+              <a:t> enterprises.</a:t>
+            </a:r>
+          </a:p>
+          <a:p>
+            <a:pPr algn="just">
               <a:spcAft>
                 <a:spcPts val="800"/>
               </a:spcAft>
             </a:pPr>
             <a:r>
-              <a:rPr sz="1200" b="0">
+              <a:rPr sz="1200" b="0" dirty="0">
                 <a:latin typeface="Arial"/>
               </a:rPr>
               <a:t>• </a:t>
             </a:r>
             <a:r>
-              <a:rPr sz="1200" b="1">
+              <a:rPr sz="1200" b="1" dirty="0">
                 <a:latin typeface="Arial"/>
               </a:rPr>
               <a:t>8%–15% Bulk Sourcing Savings: </a:t>
             </a:r>
             <a:r>
-              <a:rPr sz="1200" b="0">
-                <a:latin typeface="Arial"/>
-              </a:rPr>
-              <a:t>Combines common purchasing demand across all oil companies to secure high-volume discounts on the Government e-Marketplace (GeM).</a:t>
-            </a:r>
-          </a:p>
-          <a:p>
-            <a:pPr>
+              <a:rPr sz="1200" b="0" dirty="0">
+                <a:latin typeface="Arial"/>
+              </a:rPr>
+              <a:t>Combines common purchasing demand across all oil companies to secure high-volume discounts on the Government e-Marketplace (</a:t>
+            </a:r>
+            <a:r>
+              <a:rPr sz="1200" b="0" dirty="0" err="1">
+                <a:latin typeface="Arial"/>
+              </a:rPr>
+              <a:t>GeM</a:t>
+            </a:r>
+            <a:r>
+              <a:rPr sz="1200" b="0" dirty="0">
+                <a:latin typeface="Arial"/>
+              </a:rPr>
+              <a:t>).</a:t>
+            </a:r>
+          </a:p>
+          <a:p>
+            <a:pPr algn="just">
               <a:spcAft>
                 <a:spcPts val="800"/>
               </a:spcAft>
             </a:pPr>
             <a:r>
-              <a:rPr sz="1200" b="0">
+              <a:rPr sz="1200" b="0" dirty="0">
                 <a:latin typeface="Arial"/>
               </a:rPr>
               <a:t>• </a:t>
             </a:r>
             <a:r>
-              <a:rPr sz="1200" b="1">
+              <a:rPr sz="1200" b="1" dirty="0">
                 <a:latin typeface="Arial"/>
               </a:rPr>
               <a:t>Eliminates Rush-Purchase Premiums: </a:t>
             </a:r>
             <a:r>
-              <a:rPr sz="1200" b="0">
+              <a:rPr sz="1200" b="0" dirty="0">
                 <a:latin typeface="Arial"/>
               </a:rPr>
               <a:t>Avoids paying inflated spot-market prices and expensive emergency air-freight shipping during sudden equipment breakdowns.</a:t>
             </a:r>
           </a:p>
           <a:p>
-            <a:pPr>
+            <a:pPr algn="just">
               <a:spcAft>
                 <a:spcPts val="800"/>
               </a:spcAft>
             </a:pPr>
             <a:r>
-              <a:rPr sz="1200" b="0">
+              <a:rPr sz="1200" b="0" dirty="0">
                 <a:latin typeface="Arial"/>
               </a:rPr>
               <a:t>• </a:t>
             </a:r>
             <a:r>
-              <a:rPr sz="1200" b="1">
+              <a:rPr sz="1200" b="1" dirty="0">
                 <a:latin typeface="Arial"/>
               </a:rPr>
               <a:t>Lower Warehouse Holding Costs: </a:t>
             </a:r>
             <a:r>
-              <a:rPr sz="1200" b="0">
+              <a:rPr sz="1200" b="0" dirty="0">
                 <a:latin typeface="Arial"/>
               </a:rPr>
               <a:t>Reduces storage crowding, insurance fees, and obsolescence waste by sharing slow-moving backup and insurance spares.</a:t>
@@ -9145,7 +9291,7 @@
         <p:spPr>
           <a:xfrm>
             <a:off x="8360101" y="1400092"/>
-            <a:ext cx="3632219" cy="4389120"/>
+            <a:ext cx="3632219" cy="3544560"/>
           </a:xfrm>
           <a:prstGeom prst="rect">
             <a:avLst/>
@@ -9158,113 +9304,119 @@
           </a:bodyPr>
           <a:lstStyle/>
           <a:p>
-            <a:pPr>
+            <a:pPr algn="just">
               <a:spcAft>
                 <a:spcPts val="1000"/>
               </a:spcAft>
             </a:pPr>
             <a:r>
-              <a:rPr sz="1600" b="1">
+              <a:rPr sz="1600" b="1" dirty="0">
                 <a:latin typeface="Arial"/>
               </a:rPr>
               <a:t>Social, Strategic &amp; Green</a:t>
             </a:r>
           </a:p>
           <a:p>
-            <a:pPr>
+            <a:pPr algn="just">
               <a:spcAft>
                 <a:spcPts val="800"/>
               </a:spcAft>
             </a:pPr>
             <a:r>
-              <a:rPr sz="1200" b="0">
+              <a:rPr sz="1200" b="0" dirty="0">
                 <a:latin typeface="Arial"/>
               </a:rPr>
               <a:t>• </a:t>
             </a:r>
             <a:r>
-              <a:rPr sz="1200" b="1">
-                <a:latin typeface="Arial"/>
-              </a:rPr>
-              <a:t>Aatmanirbhar Bharat: </a:t>
-            </a:r>
-            <a:r>
-              <a:rPr sz="1200" b="0">
+              <a:rPr sz="1200" b="1" dirty="0" err="1">
+                <a:latin typeface="Arial"/>
+              </a:rPr>
+              <a:t>Aatmanirbhar</a:t>
+            </a:r>
+            <a:r>
+              <a:rPr sz="1200" b="1" dirty="0">
+                <a:latin typeface="Arial"/>
+              </a:rPr>
+              <a:t> Bharat: </a:t>
+            </a:r>
+            <a:r>
+              <a:rPr sz="1200" b="0" dirty="0">
                 <a:latin typeface="Arial"/>
               </a:rPr>
               <a:t>Builds sovereign digital infrastructure for India's energy sector, strengthening energy security and cutting foreign import dependency.</a:t>
             </a:r>
           </a:p>
           <a:p>
-            <a:pPr>
+            <a:pPr algn="just">
               <a:spcAft>
                 <a:spcPts val="800"/>
               </a:spcAft>
             </a:pPr>
             <a:r>
-              <a:rPr sz="1200" b="0">
+              <a:rPr sz="1200" b="0" dirty="0">
                 <a:latin typeface="Arial"/>
               </a:rPr>
               <a:t>• </a:t>
             </a:r>
             <a:r>
-              <a:rPr sz="1200" b="1">
+              <a:rPr sz="1200" b="1" dirty="0">
                 <a:latin typeface="Arial"/>
               </a:rPr>
               <a:t>Zero Industrial Accidents: </a:t>
             </a:r>
             <a:r>
-              <a:rPr sz="1200" b="0">
+              <a:rPr sz="1200" b="0" dirty="0">
                 <a:latin typeface="Arial"/>
               </a:rPr>
               <a:t>Strict ASME/ASTM safety guardrails eliminate mismatched valves and flanges, preventing hazardous leaks, explosions, and plant fires.</a:t>
             </a:r>
           </a:p>
           <a:p>
-            <a:pPr>
+            <a:pPr algn="just">
               <a:spcAft>
                 <a:spcPts val="800"/>
               </a:spcAft>
             </a:pPr>
             <a:r>
-              <a:rPr sz="1200" b="0">
+              <a:rPr sz="1200" b="0" dirty="0">
                 <a:latin typeface="Arial"/>
               </a:rPr>
               <a:t>• </a:t>
             </a:r>
             <a:r>
-              <a:rPr sz="1200" b="1">
+              <a:rPr sz="1200" b="1" dirty="0">
                 <a:latin typeface="Arial"/>
               </a:rPr>
               <a:t>Greener Operations &amp; Lower Emissions: </a:t>
             </a:r>
             <a:r>
-              <a:rPr sz="1200" b="0">
+              <a:rPr sz="1200" b="0" dirty="0">
                 <a:latin typeface="Arial"/>
               </a:rPr>
               <a:t>Mobilizing existing domestic surplus stock avoids unnecessary new steel manufacturing and cuts redundant transport emissions.</a:t>
             </a:r>
           </a:p>
           <a:p>
-            <a:pPr>
+            <a:pPr algn="just">
               <a:spcAft>
                 <a:spcPts val="800"/>
               </a:spcAft>
             </a:pPr>
             <a:r>
-              <a:rPr sz="1200" b="0">
+              <a:rPr sz="1200" b="0" dirty="0">
                 <a:latin typeface="Arial"/>
               </a:rPr>
               <a:t>• </a:t>
             </a:r>
             <a:r>
-              <a:rPr sz="1200" b="1">
+              <a:rPr sz="1200" b="1" dirty="0">
                 <a:latin typeface="Arial"/>
               </a:rPr>
               <a:t>Inter-PSU Collaboration: </a:t>
             </a:r>
             <a:r>
-              <a:rPr sz="1200" b="0">
+              <a:rPr sz="1200" b="0" dirty="0">
                 <a:latin typeface="Arial"/>
               </a:rPr>
               <a:t>Pioneers seamless resource sharing and cooperative governance across India's premier public sector enterprises.</a:t>
@@ -9282,6 +9434,9 @@
   <p:clrMapOvr>
     <a:masterClrMapping/>
   </p:clrMapOvr>
+  <p:transition spd="slow">
+    <p:wipe/>
+  </p:transition>
 </p:sld>
 </file>
 
@@ -9668,7 +9823,7 @@
               <a:t>High-speed graph search in </a:t>
             </a:r>
             <a:r>
-              <a:rPr sz="1200" b="0">
+              <a:rPr sz="1200" b="0" dirty="0" err="1">
                 <a:latin typeface="Arial"/>
               </a:rPr>
               <a:t>Qdrant</a:t>
@@ -9968,8 +10123,8 @@
           <a:p>
             <a:pPr algn="ctr"/>
             <a:r>
-              <a:rPr lang="en-US" dirty="0"/>
-              <a:t>Your Team Name</a:t>
+              <a:rPr lang="en-US" dirty="0" err="1"/>
+              <a:t>BharatCodex</a:t>
             </a:r>
             <a:endParaRPr lang="en-IN" dirty="0"/>
           </a:p>
@@ -10015,6 +10170,9 @@
   <p:clrMapOvr>
     <a:masterClrMapping/>
   </p:clrMapOvr>
+  <p:transition spd="slow">
+    <p:wipe/>
+  </p:transition>
 </p:sld>
 </file>
 

</xml_diff>

<commit_message>
feat(auth): implement production RBAC, super admin approval workflow, and GovTech landing page
</commit_message>
<xml_diff>
--- a/SIH_Presentation.pptx
+++ b/SIH_Presentation.pptx
@@ -26,7 +26,7 @@
       <p:boldItalic r:id="rId12"/>
     </p:embeddedFont>
     <p:embeddedFont>
-      <p:font typeface="Oswald" panose="00000500000000000000" pitchFamily="2" charset="0"/>
+      <p:font typeface="Oswald" panose="020F0502020204030204" pitchFamily="2" charset="0"/>
       <p:regular r:id="rId13"/>
       <p:bold r:id="rId14"/>
     </p:embeddedFont>
@@ -276,7 +276,7 @@
       </p15:sldGuideLst>
     </p:ext>
     <p:ext uri="GoogleSlidesCustomDataVersion2">
-      <go:slidesCustomData xmlns:go="http://customooxmlschemas.google.com/" xmlns:ahyp="http://schemas.microsoft.com/office/drawing/2018/hyperlinkcolor" xmlns:p15="http://schemas.microsoft.com/office/powerpoint/2012/main" xmlns:p14="http://schemas.microsoft.com/office/powerpoint/2010/main" xmlns:com="http://schemas.openxmlformats.org/drawingml/2006/compatibility" xmlns:pvml="urn:schemas-microsoft-com:office:powerpoint" xmlns:v="urn:schemas-microsoft-com:vml" xmlns:o="urn:schemas-microsoft-com:office:office" xmlns:dgm="http://schemas.openxmlformats.org/drawingml/2006/diagram" xmlns:c="http://schemas.openxmlformats.org/drawingml/2006/chart" xmlns:mv="urn:schemas-microsoft-com:mac:vml" xmlns:mc="http://schemas.openxmlformats.org/markup-compatibility/2006" xmlns="" r:id="rId19" roundtripDataSignature="AMtx7mgSta+fZv5Zqp4IgHLUMy4tewOjuw=="/>
+      <go:slidesCustomData xmlns="" xmlns:mc="http://schemas.openxmlformats.org/markup-compatibility/2006" xmlns:mv="urn:schemas-microsoft-com:mac:vml" xmlns:c="http://schemas.openxmlformats.org/drawingml/2006/chart" xmlns:dgm="http://schemas.openxmlformats.org/drawingml/2006/diagram" xmlns:o="urn:schemas-microsoft-com:office:office" xmlns:v="urn:schemas-microsoft-com:vml" xmlns:pvml="urn:schemas-microsoft-com:office:powerpoint" xmlns:com="http://schemas.openxmlformats.org/drawingml/2006/compatibility" xmlns:p14="http://schemas.microsoft.com/office/powerpoint/2010/main" xmlns:p15="http://schemas.microsoft.com/office/powerpoint/2012/main" xmlns:ahyp="http://schemas.microsoft.com/office/drawing/2018/hyperlinkcolor" xmlns:go="http://customooxmlschemas.google.com/" r:id="rId19" roundtripDataSignature="AMtx7mgSta+fZv5Zqp4IgHLUMy4tewOjuw=="/>
     </p:ext>
   </p:extLst>
 </p:presentation>
@@ -14020,7 +14020,7 @@
               </a:spcAft>
               <a:buNone/>
             </a:pPr>
-            <a:endParaRPr sz="1800">
+            <a:endParaRPr sz="1800" dirty="0">
               <a:solidFill>
                 <a:schemeClr val="dk1"/>
               </a:solidFill>
@@ -14041,7 +14041,7 @@
               <a:buNone/>
             </a:pPr>
             <a:r>
-              <a:rPr lang="en-US" sz="2000" b="1">
+              <a:rPr lang="en-US" sz="2000" b="1" dirty="0">
                 <a:solidFill>
                   <a:schemeClr val="dk1"/>
                 </a:solidFill>
@@ -14053,7 +14053,7 @@
               <a:t>Problem Statement ID: </a:t>
             </a:r>
             <a:r>
-              <a:rPr lang="en-US" sz="2000" b="0">
+              <a:rPr lang="en-US" sz="2000" b="0" dirty="0">
                 <a:solidFill>
                   <a:schemeClr val="dk1"/>
                 </a:solidFill>
@@ -14064,7 +14064,7 @@
               </a:rPr>
               <a:t>SIH26099</a:t>
             </a:r>
-            <a:endParaRPr/>
+            <a:endParaRPr dirty="0"/>
           </a:p>
           <a:p>
             <a:pPr marL="0" marR="0" lvl="0" indent="0" algn="l" rtl="0">
@@ -14077,7 +14077,7 @@
               <a:buNone/>
             </a:pPr>
             <a:r>
-              <a:rPr lang="en-US" sz="2000" b="1">
+              <a:rPr lang="en-US" sz="2000" b="1" dirty="0">
                 <a:solidFill>
                   <a:schemeClr val="dk1"/>
                 </a:solidFill>
@@ -14089,7 +14089,7 @@
               <a:t>Problem Statement Title: </a:t>
             </a:r>
             <a:r>
-              <a:rPr lang="en-US" sz="2000" b="0">
+              <a:rPr lang="en-US" sz="2000" b="0" dirty="0">
                 <a:solidFill>
                   <a:schemeClr val="dk1"/>
                 </a:solidFill>
@@ -14098,9 +14098,33 @@
                 <a:cs typeface="Arial"/>
                 <a:sym typeface="Arial"/>
               </a:rPr>
-              <a:t>AI-Driven Standardization and Harmonization of Material Codes Across CPSEs (MoPNG)</a:t>
+              <a:t>AI-Driven Standardization and Harmonization of Material Codes Across CPSEs (</a:t>
             </a:r>
-            <a:endParaRPr/>
+            <a:r>
+              <a:rPr lang="en-US" sz="2000" b="0" dirty="0" err="1">
+                <a:solidFill>
+                  <a:schemeClr val="dk1"/>
+                </a:solidFill>
+                <a:latin typeface="Arial"/>
+                <a:ea typeface="Arial"/>
+                <a:cs typeface="Arial"/>
+                <a:sym typeface="Arial"/>
+              </a:rPr>
+              <a:t>MoPNG</a:t>
+            </a:r>
+            <a:r>
+              <a:rPr lang="en-US" sz="2000" b="0" dirty="0">
+                <a:solidFill>
+                  <a:schemeClr val="dk1"/>
+                </a:solidFill>
+                <a:latin typeface="Arial"/>
+                <a:ea typeface="Arial"/>
+                <a:cs typeface="Arial"/>
+                <a:sym typeface="Arial"/>
+              </a:rPr>
+              <a:t>)</a:t>
+            </a:r>
+            <a:endParaRPr dirty="0"/>
           </a:p>
           <a:p>
             <a:pPr marL="0" marR="0" lvl="0" indent="0" algn="l" rtl="0">
@@ -14113,7 +14137,7 @@
               <a:buNone/>
             </a:pPr>
             <a:r>
-              <a:rPr lang="en-US" sz="2000" b="1">
+              <a:rPr lang="en-US" sz="2000" b="1" dirty="0">
                 <a:solidFill>
                   <a:schemeClr val="dk1"/>
                 </a:solidFill>
@@ -14125,7 +14149,7 @@
               <a:t>Theme: </a:t>
             </a:r>
             <a:r>
-              <a:rPr lang="en-US" sz="2000" b="0">
+              <a:rPr lang="en-US" sz="2000" b="0" dirty="0">
                 <a:solidFill>
                   <a:schemeClr val="dk1"/>
                 </a:solidFill>
@@ -14136,7 +14160,7 @@
               </a:rPr>
               <a:t>Smart Automation / Clean &amp; Green Technology</a:t>
             </a:r>
-            <a:endParaRPr/>
+            <a:endParaRPr dirty="0"/>
           </a:p>
           <a:p>
             <a:pPr marL="0" marR="0" lvl="0" indent="0" algn="l" rtl="0">
@@ -14149,7 +14173,7 @@
               <a:buNone/>
             </a:pPr>
             <a:r>
-              <a:rPr lang="en-US" sz="2000" b="1">
+              <a:rPr lang="en-US" sz="2000" b="1" dirty="0">
                 <a:solidFill>
                   <a:schemeClr val="dk1"/>
                 </a:solidFill>
@@ -14161,7 +14185,7 @@
               <a:t>PS Category: </a:t>
             </a:r>
             <a:r>
-              <a:rPr lang="en-US" sz="2000" b="0">
+              <a:rPr lang="en-US" sz="2000" b="0" dirty="0">
                 <a:solidFill>
                   <a:schemeClr val="dk1"/>
                 </a:solidFill>
@@ -14172,7 +14196,7 @@
               </a:rPr>
               <a:t>Software</a:t>
             </a:r>
-            <a:endParaRPr/>
+            <a:endParaRPr dirty="0"/>
           </a:p>
           <a:p>
             <a:pPr marL="0" marR="0" lvl="0" indent="0" algn="l" rtl="0">
@@ -14185,7 +14209,7 @@
               <a:buNone/>
             </a:pPr>
             <a:r>
-              <a:rPr lang="en-US" sz="2000" b="1">
+              <a:rPr lang="en-US" sz="2000" b="1" dirty="0">
                 <a:solidFill>
                   <a:schemeClr val="dk1"/>
                 </a:solidFill>
@@ -14197,14 +14221,14 @@
               <a:t>Team ID: </a:t>
             </a:r>
             <a:r>
-              <a:rPr lang="en-US" sz="2000">
+              <a:rPr lang="en-US" sz="2000" dirty="0">
                 <a:solidFill>
                   <a:schemeClr val="dk1"/>
                 </a:solidFill>
               </a:rPr>
-              <a:t>26P30</a:t>
+              <a:t>168042</a:t>
             </a:r>
-            <a:endParaRPr sz="2000" b="0">
+            <a:endParaRPr sz="2000" b="0" dirty="0">
               <a:solidFill>
                 <a:schemeClr val="dk1"/>
               </a:solidFill>
@@ -14225,7 +14249,7 @@
               <a:buNone/>
             </a:pPr>
             <a:r>
-              <a:rPr lang="en-US" sz="2000" b="1">
+              <a:rPr lang="en-US" sz="2000" b="1" dirty="0">
                 <a:solidFill>
                   <a:schemeClr val="dk1"/>
                 </a:solidFill>
@@ -14237,7 +14261,7 @@
               <a:t>Team Name: </a:t>
             </a:r>
             <a:r>
-              <a:rPr lang="en-US" sz="2000" b="0">
+              <a:rPr lang="en-US" sz="2000" b="0" dirty="0" err="1">
                 <a:solidFill>
                   <a:schemeClr val="dk1"/>
                 </a:solidFill>
@@ -14248,7 +14272,7 @@
               </a:rPr>
               <a:t>BharatCodex</a:t>
             </a:r>
-            <a:endParaRPr sz="2000" b="0">
+            <a:endParaRPr sz="2000" b="0" dirty="0">
               <a:solidFill>
                 <a:schemeClr val="dk1"/>
               </a:solidFill>
@@ -14329,7 +14353,7 @@
               <a:buSzPts val="3200"/>
               <a:buNone/>
             </a:pPr>
-            <a:endParaRPr/>
+            <a:endParaRPr dirty="0"/>
           </a:p>
           <a:p>
             <a:pPr marL="0" lvl="0" indent="0" algn="ctr" rtl="0">
@@ -14345,7 +14369,7 @@
               <a:buSzPts val="3200"/>
               <a:buNone/>
             </a:pPr>
-            <a:endParaRPr/>
+            <a:endParaRPr dirty="0"/>
           </a:p>
         </p:txBody>
       </p:sp>
@@ -14360,7 +14384,7 @@
         <p:fade/>
       </p:transition>
     </mc:Choice>
-    <mc:Fallback xmlns:ahyp="http://schemas.microsoft.com/office/drawing/2018/hyperlinkcolor" xmlns:p15="http://schemas.microsoft.com/office/powerpoint/2012/main" xmlns:com="http://schemas.openxmlformats.org/drawingml/2006/compatibility" xmlns:pvml="urn:schemas-microsoft-com:office:powerpoint" xmlns:v="urn:schemas-microsoft-com:vml" xmlns:o="urn:schemas-microsoft-com:office:office" xmlns:dgm="http://schemas.openxmlformats.org/drawingml/2006/diagram" xmlns:c="http://schemas.openxmlformats.org/drawingml/2006/chart" xmlns:mv="urn:schemas-microsoft-com:mac:vml" xmlns="">
+    <mc:Fallback xmlns="" xmlns:mv="urn:schemas-microsoft-com:mac:vml" xmlns:c="http://schemas.openxmlformats.org/drawingml/2006/chart" xmlns:dgm="http://schemas.openxmlformats.org/drawingml/2006/diagram" xmlns:o="urn:schemas-microsoft-com:office:office" xmlns:v="urn:schemas-microsoft-com:vml" xmlns:pvml="urn:schemas-microsoft-com:office:powerpoint" xmlns:com="http://schemas.openxmlformats.org/drawingml/2006/compatibility" xmlns:p15="http://schemas.microsoft.com/office/powerpoint/2012/main" xmlns:ahyp="http://schemas.microsoft.com/office/drawing/2018/hyperlinkcolor">
       <p:transition spd="slow">
         <p:fade/>
       </p:transition>

</xml_diff>